<commit_message>
docs(agentic-moe-2026): WT11 MAOS Hub reframe (WAVE 4) — series banners + CONSOLIDATED/deck regen
- Reframe banner (ADR-006 Accepted 2026-06-29) inserted after the title of the
  8 series files — additive, dated history preserved. Acceptance (DoD-gate):
  grep -rl 'Reframe — MAOS Hub (ADR-006' research/agentic-moe-2026/*.md | wc -l == 8
- CONSOLIDATED.html retitled 'MAOS Hub (Agentic MoE 2026) — …' + cover reframe
  banner; CONSOLIDATED.pdf re-printed from the updated HTML (headless Chrome;
  PDF /Title metadata carries the new name); exec-deck.pptx title slide
  re-titled (3 runs via python-pptx).
- CHANGELOG [Unreleased] WT11 entry added; MVV touch deliberately EXCLUDED
  (HITL-escalated per ADR-006/ADR-007 — dedicated ratification PR).

Agent: Claude-Dev-quiesce-wt11 | 2026-07-02T11:05:00-03:00
Co-Authored-By: Claude Fable 5 <noreply@anthropic.com>
</commit_message>
<xml_diff>
--- a/research/agentic-moe-2026/20260627-exec-deck.pptx
+++ b/research/agentic-moe-2026/20260627-exec-deck.pptx
@@ -3222,7 +3222,7 @@
                 </a:solidFill>
                 <a:latin typeface="Cambria"/>
               </a:rPr>
-              <a:t>Agentic MoE 2026</a:t>
+              <a:t>MAOS Hub</a:t>
             </a:r>
           </a:p>
         </p:txBody>
@@ -3264,7 +3264,7 @@
                 </a:solidFill>
                 <a:latin typeface="Calibri"/>
               </a:rPr>
-              <a:t>Landscape &amp; Hub Orquestrador</a:t>
+              <a:t>Landscape &amp; Gating-Network (Agentic MoE 2026)</a:t>
             </a:r>
           </a:p>
         </p:txBody>
@@ -3390,7 +3390,7 @@
                 </a:solidFill>
                 <a:latin typeface="Calibri"/>
               </a:rPr>
-              <a:t>2026-06-27</a:t>
+              <a:t>2026-06-27 · reframe ADR-006 (Accepted 2026-06-29)</a:t>
             </a:r>
           </a:p>
         </p:txBody>

</xml_diff>